<commit_message>
supplier: move origination into Factorio AI chat
</commit_message>
<xml_diff>
--- a/docs/factorio_user_guide_2026-07-26_en.pptx
+++ b/docs/factorio_user_guide_2026-07-26_en.pptx
@@ -5162,7 +5162,7 @@
                   <a:srgbClr val="14231B"/>
                 </a:solidFill>
               </a:rPr>
-              <a:t>•  Upload a PDF, PNG, JPEG, JSON or text invoice; three synthetic PDF samples are included for a safe demonstration.</a:t>
+              <a:t>•  Factorio AI is the supplier's default workspace: attach a PDF, image, JSON or text invoice from the chat paperclip.</a:t>
             </a:r>
           </a:p>
           <a:p>
@@ -5177,7 +5177,7 @@
                   <a:srgbClr val="14231B"/>
                 </a:solidFill>
               </a:rPr>
-              <a:t>•  Digital PDFs are converted to Markdown locally; only scanned/image-only invoices use the slower xAI vision fallback. Grok then extracts identities, dates, amount/currency, PO, tax/registration and bank details.</a:t>
+              <a:t>•  Digital PDFs become Markdown locally; only scanned/image-only invoices use the slower xAI vision fallback.</a:t>
             </a:r>
           </a:p>
           <a:p>
@@ -5192,7 +5192,7 @@
                   <a:srgbClr val="14231B"/>
                 </a:solidFill>
               </a:rPr>
-              <a:t>•  Every result includes confidence, evidence and review issues; the supplier reviews editable JSON before submission.</a:t>
+              <a:t>•  The chat presents invoice value, the percentage and amount paid today, term and monthly financing cost; bank statements or Open Banking are optional follow-ups.</a:t>
             </a:r>
           </a:p>
           <a:p>
@@ -5207,7 +5207,7 @@
                   <a:srgbClr val="14231B"/>
                 </a:solidFill>
               </a:rPr>
-              <a:t>•  Submission creates the invoice and an open marketplace financing demand atomically, using the requested or default advance rate.</a:t>
+              <a:t>•  Accepting creates the application and a one-page synthetic financing contract between Factorio Ltd and the extracted supplier.</a:t>
             </a:r>
           </a:p>
         </p:txBody>

</xml_diff>